<commit_message>
Build the submission deck for team Web Shooters
9 slides per the i4C template, every number read from results/metrics.json and the
training logs rather than typed in, so the deck cannot drift from the measurements.
</commit_message>
<xml_diff>
--- a/solution_presentation.pptx
+++ b/solution_presentation.pptx
@@ -3182,7 +3182,7 @@
               </a:defRPr>
             </a:pPr>
             <a:r>
-              <a:t>Team: PlaceholderTeam     |     COLLEGE NAME</a:t>
+              <a:t>Team: Web Shooters     |     Saintgits College of Engineering</a:t>
             </a:r>
           </a:p>
           <a:p>
@@ -3194,7 +3194,7 @@
               </a:defRPr>
             </a:pPr>
             <a:r>
-              <a:t>Members: MEMBER 1 (role), MEMBER 2 (role)</a:t>
+              <a:t>Members: Bevin Punnoose Jacob (Team Lead, ML Engineering); S Govind (Data Analysis &amp; Evaluation); Renil James (Model Architecture); Antony Thomas (Documentation &amp; Results)</a:t>
             </a:r>
           </a:p>
           <a:p>
@@ -3206,7 +3206,7 @@
               </a:defRPr>
             </a:pPr>
             <a:r>
-              <a:t>Contact: EMAIL / PHONE</a:t>
+              <a:t>Contact: bevjacob005@gmail.com  |  +91 XXXXX XXXXX</a:t>
             </a:r>
           </a:p>
           <a:p>
@@ -4852,7 +4852,7 @@
               </a:defRPr>
             </a:pPr>
             <a:r>
-              <a:t>• Stack: PyTorch. Trained on NVIDIA GeForce GTX 1650 (4 GB). No external datasets, no pretrained weights.</a:t>
+              <a:t>• Stack: PyTorch. Trained on NVIDIA GeForce GTX 1650 (4 GiB). No external datasets, no pretrained weights.</a:t>
             </a:r>
           </a:p>
           <a:p>

</xml_diff>

<commit_message>
Deck: correct team lead to S Govind and use his contact email
</commit_message>
<xml_diff>
--- a/solution_presentation.pptx
+++ b/solution_presentation.pptx
@@ -3194,7 +3194,7 @@
               </a:defRPr>
             </a:pPr>
             <a:r>
-              <a:t>Members: Bevin Punnoose Jacob (Team Lead, ML Engineering); S Govind (Data Analysis &amp; Evaluation); Renil James (Model Architecture); Antony Thomas (Documentation &amp; Results)</a:t>
+              <a:t>Members: S Govind (Team Lead); Bevin Punnoose Jacob (ML Engineering &amp; Implementation); Renil James (Data Analysis &amp; Evaluation); Antony Thomas (Documentation &amp; Results)</a:t>
             </a:r>
           </a:p>
           <a:p>
@@ -3206,7 +3206,7 @@
               </a:defRPr>
             </a:pPr>
             <a:r>
-              <a:t>Contact: bevjacob005@gmail.com  |  +91 XXXXX XXXXX</a:t>
+              <a:t>Contact: govindinferno@gmail.com</a:t>
             </a:r>
           </a:p>
           <a:p>

</xml_diff>

<commit_message>
Deck: add team lead's phone and a technical role alongside Team Lead
</commit_message>
<xml_diff>
--- a/solution_presentation.pptx
+++ b/solution_presentation.pptx
@@ -3194,7 +3194,7 @@
               </a:defRPr>
             </a:pPr>
             <a:r>
-              <a:t>Members: S Govind (Team Lead); Bevin Punnoose Jacob (ML Engineering &amp; Implementation); Renil James (Data Analysis &amp; Evaluation); Antony Thomas (Documentation &amp; Results)</a:t>
+              <a:t>Members: S Govind (Team Lead, Data Analysis &amp; Evaluation); Bevin Punnoose Jacob (ML Engineering &amp; Implementation); Renil James (Benchmarking &amp; Validation); Antony Thomas (Documentation &amp; Results)</a:t>
             </a:r>
           </a:p>
           <a:p>
@@ -3206,7 +3206,7 @@
               </a:defRPr>
             </a:pPr>
             <a:r>
-              <a:t>Contact: govindinferno@gmail.com</a:t>
+              <a:t>Contact: govindinferno@gmail.com  |  +91 80895 83726</a:t>
             </a:r>
           </a:p>
           <a:p>

</xml_diff>